<commit_message>
docs(build): dựng lại báo cáo, hướng dẫn sử dụng (xuất PDF bằng Word) và slide (#66)
</commit_message>
<xml_diff>
--- a/slides/ECMS_Nhom1.pptx
+++ b/slides/ECMS_Nhom1.pptx
@@ -869,7 +869,7 @@
           <a:lstStyle/>
           <a:p>
             <a:r>
-              <a:t>Người trình bày: Như. Chạy lại toàn bộ từ CSDL trống trong khoảng 35 giây.</a:t>
+              <a:t>Người trình bày: Như. Chạy lại toàn bộ từ CSDL trống trong 1–2 phút.</a:t>
             </a:r>
           </a:p>
         </p:txBody>
@@ -1359,7 +1359,7 @@
           <a:lstStyle/>
           <a:p>
             <a:r>
-              <a:t>Người trình bày: Như. 22 yêu cầu chức năng, 8 phi chức năng; 5 tác nhân.</a:t>
+              <a:t>Người trình bày: Như. 22 yêu cầu chức năng, 8 phi chức năng; 6 tác nhân (5 vai trò nghiệp vụ + quản trị).</a:t>
             </a:r>
           </a:p>
         </p:txBody>
@@ -1499,7 +1499,7 @@
           <a:lstStyle/>
           <a:p>
             <a:r>
-              <a:t>Người trình bày: Trâm. Sơ đồ sinh từ metadata sau khi chạy 01_schema.sql.</a:t>
+              <a:t>Người trình bày: Trâm. Sơ đồ sinh từ metadata sau khi chạy 01_schema.sql (nhóm học viên – tài chính – hệ thống). DIEMDANH, LICHHOC vi phạm 2NF có chủ đích: giữ cột để khai báo khoá ngoại phức hợp thay cho trigger.</a:t>
             </a:r>
           </a:p>
         </p:txBody>
@@ -5732,8 +5732,8 @@
         </p:blipFill>
         <p:spPr>
           <a:xfrm>
-            <a:off x="3535200" y="1044000"/>
-            <a:ext cx="4089600" cy="2556000"/>
+            <a:off x="4344621" y="1044000"/>
+            <a:ext cx="2470758" cy="2556000"/>
           </a:xfrm>
           <a:prstGeom prst="rect">
             <a:avLst/>
@@ -5761,8 +5761,8 @@
         </p:blipFill>
         <p:spPr>
           <a:xfrm>
-            <a:off x="7776000" y="1062000"/>
-            <a:ext cx="4031999" cy="2519999"/>
+            <a:off x="8682743" y="1044000"/>
+            <a:ext cx="2218513" cy="2556000"/>
           </a:xfrm>
           <a:prstGeom prst="rect">
             <a:avLst/>
@@ -5802,7 +5802,7 @@
               </a:spcAft>
             </a:pPr>
             <a:r>
-              <a:rPr sz="1200">
+              <a:rPr sz="1100">
                 <a:solidFill>
                   <a:srgbClr val="2E75B6"/>
                 </a:solidFill>
@@ -5811,7 +5811,7 @@
               <a:t>■  </a:t>
             </a:r>
             <a:r>
-              <a:rPr sz="1800" b="1">
+              <a:rPr sz="1700" b="1">
                 <a:solidFill>
                   <a:srgbClr val="1F3864"/>
                 </a:solidFill>
@@ -5820,7 +5820,7 @@
               <a:t>Menu rộng &amp; nông: </a:t>
             </a:r>
             <a:r>
-              <a:rPr sz="1800">
+              <a:rPr sz="1700">
                 <a:latin typeface="Times New Roman"/>
               </a:rPr>
               <a:t>2 cấp, 8 nhóm theo nghiệp vụ, ẩn theo vai trò, chặn cả truy cập bằng URL</a:t>
@@ -5833,7 +5833,7 @@
               </a:spcAft>
             </a:pPr>
             <a:r>
-              <a:rPr sz="1200">
+              <a:rPr sz="1100">
                 <a:solidFill>
                   <a:srgbClr val="2E75B6"/>
                 </a:solidFill>
@@ -5842,7 +5842,7 @@
               <a:t>■  </a:t>
             </a:r>
             <a:r>
-              <a:rPr sz="1800" b="1">
+              <a:rPr sz="1700" b="1">
                 <a:solidFill>
                   <a:srgbClr val="1F3864"/>
                 </a:solidFill>
@@ -5851,7 +5851,7 @@
               <a:t>Form: </a:t>
             </a:r>
             <a:r>
-              <a:rPr sz="1800">
+              <a:rPr sz="1700">
                 <a:latin typeface="Times New Roman"/>
               </a:rPr>
               <a:t>control theo kiểu dữ liệu, giá trị mặc định, lỗi hiện ngay dưới ô nhập + kiểm tra lần 2 tại CSDL</a:t>
@@ -5864,7 +5864,7 @@
               </a:spcAft>
             </a:pPr>
             <a:r>
-              <a:rPr sz="1200">
+              <a:rPr sz="1100">
                 <a:solidFill>
                   <a:srgbClr val="2E75B6"/>
                 </a:solidFill>
@@ -5873,7 +5873,29 @@
               <a:t>■  </a:t>
             </a:r>
             <a:r>
-              <a:rPr sz="1800">
+              <a:rPr sz="1700">
+                <a:latin typeface="Times New Roman"/>
+              </a:rPr>
+              <a:t>Xoá phải xác nhận; tài khoản chi nhánh bị khoá ở chi nhánh mình; phiên được kiểm tra lại mỗi 60 giây</a:t>
+            </a:r>
+          </a:p>
+          <a:p>
+            <a:pPr>
+              <a:spcAft>
+                <a:spcPts val="600"/>
+              </a:spcAft>
+            </a:pPr>
+            <a:r>
+              <a:rPr sz="1100">
+                <a:solidFill>
+                  <a:srgbClr val="2E75B6"/>
+                </a:solidFill>
+                <a:latin typeface="Times New Roman"/>
+              </a:rPr>
+              <a:t>■  </a:t>
+            </a:r>
+            <a:r>
+              <a:rPr sz="1700">
                 <a:latin typeface="Times New Roman"/>
               </a:rPr>
               <a:t>Ánh xạ mỗi form ↔ view / procedure / trigger – giao diện không truy cập bảng gốc</a:t>
@@ -6130,8 +6152,8 @@
         </p:blipFill>
         <p:spPr>
           <a:xfrm>
-            <a:off x="432000" y="1053000"/>
-            <a:ext cx="5616000" cy="3510000"/>
+            <a:off x="1381774" y="1044000"/>
+            <a:ext cx="3716452" cy="3528000"/>
           </a:xfrm>
           <a:prstGeom prst="rect">
             <a:avLst/>
@@ -6159,8 +6181,8 @@
         </p:blipFill>
         <p:spPr>
           <a:xfrm>
-            <a:off x="6192000" y="1053000"/>
-            <a:ext cx="5616000" cy="3510000"/>
+            <a:off x="7327700" y="1044000"/>
+            <a:ext cx="3344599" cy="3528000"/>
           </a:xfrm>
           <a:prstGeom prst="rect">
             <a:avLst/>
@@ -6491,8 +6513,8 @@
         </p:blipFill>
         <p:spPr>
           <a:xfrm>
-            <a:off x="439200" y="1044000"/>
-            <a:ext cx="6105600" cy="3816000"/>
+            <a:off x="2613616" y="1044000"/>
+            <a:ext cx="1756768" cy="3816000"/>
           </a:xfrm>
           <a:prstGeom prst="rect">
             <a:avLst/>
@@ -6520,8 +6542,8 @@
         </p:blipFill>
         <p:spPr>
           <a:xfrm>
-            <a:off x="6696000" y="1899182"/>
-            <a:ext cx="2520000" cy="3563636"/>
+            <a:off x="6696000" y="1899212"/>
+            <a:ext cx="2520000" cy="3563576"/>
           </a:xfrm>
           <a:prstGeom prst="rect">
             <a:avLst/>
@@ -6561,7 +6583,7 @@
               </a:spcAft>
             </a:pPr>
             <a:r>
-              <a:rPr sz="1000">
+              <a:rPr sz="900">
                 <a:solidFill>
                   <a:srgbClr val="2E75B6"/>
                 </a:solidFill>
@@ -6570,7 +6592,7 @@
               <a:t>■  </a:t>
             </a:r>
             <a:r>
-              <a:rPr sz="1600" b="1">
+              <a:rPr sz="1500" b="1">
                 <a:solidFill>
                   <a:srgbClr val="1F3864"/>
                 </a:solidFill>
@@ -6579,7 +6601,7 @@
               <a:t>9 báo cáo: </a:t>
             </a:r>
             <a:r>
-              <a:rPr sz="1600">
+              <a:rPr sz="1500">
                 <a:latin typeface="Times New Roman"/>
               </a:rPr>
               <a:t>định kỳ, theo yêu cầu, tổng hợp, biểu mẫu</a:t>
@@ -6592,7 +6614,7 @@
               </a:spcAft>
             </a:pPr>
             <a:r>
-              <a:rPr sz="1000">
+              <a:rPr sz="900">
                 <a:solidFill>
                   <a:srgbClr val="2E75B6"/>
                 </a:solidFill>
@@ -6601,10 +6623,10 @@
               <a:t>■  </a:t>
             </a:r>
             <a:r>
-              <a:rPr sz="1600">
-                <a:latin typeface="Times New Roman"/>
-              </a:rPr>
-              <a:t>PDF + Excel</a:t>
+              <a:rPr sz="1500">
+                <a:latin typeface="Times New Roman"/>
+              </a:rPr>
+              <a:t>PDF (A4 / A5) + Excel + Word, giữ tô màu và dòng TB / Min / Max</a:t>
             </a:r>
           </a:p>
           <a:p>
@@ -6614,7 +6636,7 @@
               </a:spcAft>
             </a:pPr>
             <a:r>
-              <a:rPr sz="1000">
+              <a:rPr sz="900">
                 <a:solidFill>
                   <a:srgbClr val="2E75B6"/>
                 </a:solidFill>
@@ -6623,10 +6645,32 @@
               <a:t>■  </a:t>
             </a:r>
             <a:r>
-              <a:rPr sz="1600">
-                <a:latin typeface="Times New Roman"/>
-              </a:rPr>
-              <a:t>Dashboard 6 KPI so kỳ trước, đọc từ indexed view</a:t>
+              <a:rPr sz="1500">
+                <a:latin typeface="Times New Roman"/>
+              </a:rPr>
+              <a:t>Dashboard 6 KPI có mốc so sánh; KPI doanh thu đọc từ indexed view</a:t>
+            </a:r>
+          </a:p>
+          <a:p>
+            <a:pPr>
+              <a:spcAft>
+                <a:spcPts val="600"/>
+              </a:spcAft>
+            </a:pPr>
+            <a:r>
+              <a:rPr sz="900">
+                <a:solidFill>
+                  <a:srgbClr val="2E75B6"/>
+                </a:solidFill>
+                <a:latin typeface="Times New Roman"/>
+              </a:rPr>
+              <a:t>■  </a:t>
+            </a:r>
+            <a:r>
+              <a:rPr sz="1500">
+                <a:latin typeface="Times New Roman"/>
+              </a:rPr>
+              <a:t>So sánh với Crystal Report (Lab 4)</a:t>
             </a:r>
           </a:p>
         </p:txBody>
@@ -7686,7 +7730,7 @@
                           </a:solidFill>
                           <a:latin typeface="Times New Roman"/>
                         </a:rPr>
-                        <a:t>ODL + mapper Python</a:t>
+                        <a:t>ODL 16 lớp, OID, 3 cách ánh xạ kế thừa</a:t>
                       </a:r>
                     </a:p>
                   </a:txBody>
@@ -7709,7 +7753,7 @@
                           </a:solidFill>
                           <a:latin typeface="Times New Roman"/>
                         </a:rPr>
-                        <a:t>3 trạm + partitioned view</a:t>
+                        <a:t>3 trạm, nửa kết −73% byte, 2PC</a:t>
                       </a:r>
                     </a:p>
                   </a:txBody>
@@ -7732,7 +7776,7 @@
                           </a:solidFill>
                           <a:latin typeface="Times New Roman"/>
                         </a:rPr>
-                        <a:t>4 collection, 6 cặp truy vấn</a:t>
+                        <a:t>4 collection, 6 đọc + 3 ghi</a:t>
                       </a:r>
                     </a:p>
                   </a:txBody>
@@ -8122,7 +8166,7 @@
                           </a:solidFill>
                           <a:latin typeface="Times New Roman"/>
                         </a:rPr>
-                        <a:t>≈ 10 giây</a:t>
+                        <a:t>≈ 20 giây</a:t>
                       </a:r>
                     </a:p>
                   </a:txBody>
@@ -8218,7 +8262,7 @@
                           </a:solidFill>
                           <a:latin typeface="Times New Roman"/>
                         </a:rPr>
-                        <a:t>25 / 17 / 36 ca PASS</a:t>
+                        <a:t>37 / 22 / 50 ca PASS</a:t>
                       </a:r>
                     </a:p>
                   </a:txBody>
@@ -8291,7 +8335,7 @@
                           </a:solidFill>
                           <a:latin typeface="Times New Roman"/>
                         </a:rPr>
-                        <a:t>Smoke test mọi trang × 5 vai trò + mọi báo cáo</a:t>
+                        <a:t>Ứng dụng: mọi trang × vai trò, báo cáo PDF / Excel / Word</a:t>
                       </a:r>
                     </a:p>
                   </a:txBody>
@@ -8314,7 +8358,7 @@
                           </a:solidFill>
                           <a:latin typeface="Times New Roman"/>
                         </a:rPr>
-                        <a:t>52 passed</a:t>
+                        <a:t>125 passed</a:t>
                       </a:r>
                     </a:p>
                   </a:txBody>
@@ -8378,7 +8422,7 @@
               <a:rPr sz="1800">
                 <a:latin typeface="Times New Roman"/>
               </a:rPr>
-              <a:t>SQL Server 2025 (Docker) → run_all → test SQL → pytest</a:t>
+              <a:t>SQL Server 2025 (Docker) → run_all → test SQL → pytest, khi PR / push vào main</a:t>
             </a:r>
           </a:p>
           <a:p>
@@ -8400,7 +8444,7 @@
               <a:rPr sz="1800">
                 <a:latin typeface="Times New Roman"/>
               </a:rPr>
-              <a:t>Bắt buộc xanh trước khi merge develop → main</a:t>
+              <a:t>Healthcheck chờ đổi collation xong – sửa lỗi CI ngày 20/10</a:t>
             </a:r>
           </a:p>
           <a:p>
@@ -8431,7 +8475,7 @@
               <a:rPr sz="1800">
                 <a:latin typeface="Times New Roman"/>
               </a:rPr>
-              <a:t>29 task = 29 issue = 29 PR vào develop, review bởi nhóm trưởng</a:t>
+              <a:t>30 task = 30 issue, PR vào develop, review bởi nhóm trưởng</a:t>
             </a:r>
           </a:p>
           <a:p>
@@ -8453,7 +8497,7 @@
               <a:rPr sz="1800">
                 <a:latin typeface="Times New Roman"/>
               </a:rPr>
-              <a:t>Phát hành v1.0.0</a:t>
+              <a:t>Rà soát theo bài giảng → T30 khắc phục, đo lại số liệu</a:t>
             </a:r>
           </a:p>
         </p:txBody>
@@ -9765,7 +9809,7 @@
                           </a:solidFill>
                           <a:latin typeface="Times New Roman"/>
                         </a:rPr>
-                        <a:t>T01–T03, T15, T19, T29</a:t>
+                        <a:t>T01–T03, T15, T19, T29, T30</a:t>
                       </a:r>
                     </a:p>
                   </a:txBody>
@@ -9788,7 +9832,7 @@
                           </a:solidFill>
                           <a:latin typeface="Times New Roman"/>
                         </a:rPr>
-                        <a:t>Quản lý dự án, Chương 1, môi trường, phân quyền, khung web, CI, tổng hợp</a:t>
+                        <a:t>Quản lý dự án, Chương 1, môi trường, phân quyền, khung web, CI, tổng hợp, khắc phục</a:t>
                       </a:r>
                     </a:p>
                   </a:txBody>
@@ -10506,7 +10550,7 @@
               <a:rPr sz="1700">
                 <a:latin typeface="Times New Roman"/>
               </a:rPr>
-              <a:t>Thu thập → Tổ chức → Xử lý → Trình bày</a:t>
+              <a:t>Thu thập → Tổ chức → Chuyển đổi → Trình bày → An toàn</a:t>
             </a:r>
           </a:p>
           <a:p>
@@ -10581,7 +10625,7 @@
               <a:rPr sz="1900">
                 <a:latin typeface="Times New Roman"/>
               </a:rPr>
-              <a:t>dữ liệu nhỏ, giao diện chưa tối ưu di động, phân tán mới mô phỏng trên 1 máy</a:t>
+              <a:t>dữ liệu nhỏ, chưa có phím tắt và giao diện di động, phân tán mô phỏng trên 1 máy (MSDTC 2 máy chạy trên Windows)</a:t>
             </a:r>
           </a:p>
         </p:txBody>
@@ -10714,7 +10758,7 @@
               <a:rPr sz="1700">
                 <a:latin typeface="Times New Roman"/>
               </a:rPr>
-              <a:t>Kho dữ liệu và dự báo học viên bỏ học (tầng Wisdom)</a:t>
+              <a:t>Kho dữ liệu và dự báo học viên bỏ học (tầng Trí tuệ)</a:t>
             </a:r>
           </a:p>
         </p:txBody>
@@ -13054,13 +13098,13 @@
                 </a:solidFill>
                 <a:latin typeface="Times New Roman"/>
               </a:rPr>
-              <a:t>Ánh xạ DIKW: </a:t>
+              <a:t>DIKW trên số liệu thật: </a:t>
             </a:r>
             <a:r>
               <a:rPr sz="1800">
                 <a:latin typeface="Times New Roman"/>
               </a:rPr>
-              <a:t>điểm danh → chuyên cần → cảnh báo bỏ học</a:t>
+              <a:t>10.063 điểm danh → HV0021 chuyên cần 56,25% → chuyên cần &lt; 80% thì không đạt 33,3% (gấp 3) → gọi điện, học bù</a:t>
             </a:r>
           </a:p>
         </p:txBody>
@@ -13370,7 +13414,7 @@
                 </a:solidFill>
                 <a:latin typeface="Times New Roman"/>
               </a:rPr>
-              <a:t>17 tập thực thể: </a:t>
+              <a:t>14 tập thực thể: </a:t>
             </a:r>
             <a:r>
               <a:rPr sz="1800">
@@ -13700,7 +13744,7 @@
       </p:sp>
       <p:pic>
         <p:nvPicPr>
-          <p:cNvPr id="8" name="Picture 7" descr="db-diagram.png"/>
+          <p:cNvPr id="8" name="Picture 7" descr="db-diagram-2.png"/>
           <p:cNvPicPr>
             <a:picLocks noChangeAspect="1"/>
           </p:cNvPicPr>
@@ -13714,8 +13758,8 @@
         </p:blipFill>
         <p:spPr>
           <a:xfrm>
-            <a:off x="2204626" y="1044000"/>
-            <a:ext cx="3474747" cy="5274000"/>
+            <a:off x="1615161" y="1044000"/>
+            <a:ext cx="4653677" cy="5274000"/>
           </a:xfrm>
           <a:prstGeom prst="rect">
             <a:avLst/>
@@ -13755,7 +13799,7 @@
               </a:spcAft>
             </a:pPr>
             <a:r>
-              <a:rPr sz="1200">
+              <a:rPr sz="1100">
                 <a:solidFill>
                   <a:srgbClr val="2E75B6"/>
                 </a:solidFill>
@@ -13764,10 +13808,10 @@
               <a:t>■  </a:t>
             </a:r>
             <a:r>
-              <a:rPr sz="1800">
-                <a:latin typeface="Times New Roman"/>
-              </a:rPr>
-              <a:t>22 bảng, 32 khoá ngoại, 22 chỉ mục</a:t>
+              <a:rPr sz="1700">
+                <a:latin typeface="Times New Roman"/>
+              </a:rPr>
+              <a:t>22 bảng, 33 khoá ngoại, 53 CHECK, 23 chỉ mục</a:t>
             </a:r>
           </a:p>
           <a:p>
@@ -13777,7 +13821,7 @@
               </a:spcAft>
             </a:pPr>
             <a:r>
-              <a:rPr sz="1200">
+              <a:rPr sz="1100">
                 <a:solidFill>
                   <a:srgbClr val="2E75B6"/>
                 </a:solidFill>
@@ -13786,19 +13830,19 @@
               <a:t>■  </a:t>
             </a:r>
             <a:r>
-              <a:rPr sz="1800" b="1">
+              <a:rPr sz="1700" b="1">
                 <a:solidFill>
                   <a:srgbClr val="1F3864"/>
                 </a:solidFill>
                 <a:latin typeface="Times New Roman"/>
               </a:rPr>
-              <a:t>Chuẩn hoá: </a:t>
-            </a:r>
-            <a:r>
-              <a:rPr sz="1800">
-                <a:latin typeface="Times New Roman"/>
-              </a:rPr>
-              <a:t>17/22 quan hệ đạt BCNF, phần còn lại có lý do giữ</a:t>
+              <a:t>Chuẩn hoá theo khoá dự tuyển: </a:t>
+            </a:r>
+            <a:r>
+              <a:rPr sz="1700">
+                <a:latin typeface="Times New Roman"/>
+              </a:rPr>
+              <a:t>16/22 BCNF, 4 quan hệ 2NF (lưu giá trị suy diễn), 2 vi phạm 2NF có chủ đích</a:t>
             </a:r>
           </a:p>
           <a:p>
@@ -13808,7 +13852,7 @@
               </a:spcAft>
             </a:pPr>
             <a:r>
-              <a:rPr sz="1200">
+              <a:rPr sz="1100">
                 <a:solidFill>
                   <a:srgbClr val="2E75B6"/>
                 </a:solidFill>
@@ -13817,19 +13861,19 @@
               <a:t>■  </a:t>
             </a:r>
             <a:r>
-              <a:rPr sz="1800" b="1">
+              <a:rPr sz="1700" b="1">
                 <a:solidFill>
                   <a:srgbClr val="1F3864"/>
                 </a:solidFill>
                 <a:latin typeface="Times New Roman"/>
               </a:rPr>
-              <a:t>RBTV: </a:t>
-            </a:r>
-            <a:r>
-              <a:rPr sz="1800">
-                <a:latin typeface="Times New Roman"/>
-              </a:rPr>
-              <a:t>CHECK, UNIQUE, FK, computed column PERSISTED, trigger</a:t>
+              <a:t>21 RBTV: </a:t>
+            </a:r>
+            <a:r>
+              <a:rPr sz="1700">
+                <a:latin typeface="Times New Roman"/>
+              </a:rPr>
+              <a:t>CHECK, UNIQUE, FK, cột tính toán, trigger</a:t>
             </a:r>
           </a:p>
           <a:p>
@@ -13839,7 +13883,7 @@
               </a:spcAft>
             </a:pPr>
             <a:r>
-              <a:rPr sz="1200">
+              <a:rPr sz="1100">
                 <a:solidFill>
                   <a:srgbClr val="2E75B6"/>
                 </a:solidFill>
@@ -13848,10 +13892,10 @@
               <a:t>■  </a:t>
             </a:r>
             <a:r>
-              <a:rPr sz="1800">
-                <a:latin typeface="Times New Roman"/>
-              </a:rPr>
-              <a:t>So sánh mô hình phẳng – quan hệ – XML</a:t>
+              <a:rPr sz="1700">
+                <a:latin typeface="Times New Roman"/>
+              </a:rPr>
+              <a:t>So sánh phẳng – phân cấp – mạng – quan hệ – XML; DTD ↔ XSD</a:t>
             </a:r>
           </a:p>
           <a:p>
@@ -13861,7 +13905,7 @@
               </a:spcAft>
             </a:pPr>
             <a:r>
-              <a:rPr sz="1200">
+              <a:rPr sz="1100">
                 <a:solidFill>
                   <a:srgbClr val="2E75B6"/>
                 </a:solidFill>
@@ -13870,10 +13914,19 @@
               <a:t>■  </a:t>
             </a:r>
             <a:r>
-              <a:rPr sz="1800">
-                <a:latin typeface="Times New Roman"/>
-              </a:rPr>
-              <a:t>Dữ liệu mẫu ~350 học viên, 25 lớp, ~500 phiếu thu</a:t>
+              <a:rPr sz="1700" b="1">
+                <a:solidFill>
+                  <a:srgbClr val="1F3864"/>
+                </a:solidFill>
+                <a:latin typeface="Times New Roman"/>
+              </a:rPr>
+              <a:t>Dữ liệu mẫu: </a:t>
+            </a:r>
+            <a:r>
+              <a:rPr sz="1700">
+                <a:latin typeface="Times New Roman"/>
+              </a:rPr>
+              <a:t>349 học viên, 25 lớp, 539 đăng ký, 501 phiếu thu</a:t>
             </a:r>
           </a:p>
         </p:txBody>
@@ -14706,7 +14759,7 @@
               <a:rPr sz="1800">
                 <a:latin typeface="Times New Roman"/>
               </a:rPr>
-              <a:t>kết quả kiểm tra đầu vào lưu cột XML có XML Schema</a:t>
+              <a:t>kết quả kiểm tra đầu vào lưu cột XML có XML Schema – 18 truy vấn XML</a:t>
             </a:r>
           </a:p>
           <a:p>
@@ -14769,10 +14822,41 @@
               <a:t>■  </a:t>
             </a:r>
             <a:r>
+              <a:rPr sz="1800" b="1">
+                <a:solidFill>
+                  <a:srgbClr val="1F3864"/>
+                </a:solidFill>
+                <a:latin typeface="Times New Roman"/>
+              </a:rPr>
+              <a:t>Chỉ mục trên 1 triệu dòng điểm danh: </a:t>
+            </a:r>
+            <a:r>
               <a:rPr sz="1800">
                 <a:latin typeface="Times New Roman"/>
               </a:rPr>
-              <a:t>Đo hiệu năng trước / sau khi thêm chỉ mục</a:t>
+              <a:t>6.023 trang → 3 trang (1 đăng ký), 150 trang (1 lớp = 3,2%)</a:t>
+            </a:r>
+          </a:p>
+          <a:p>
+            <a:pPr>
+              <a:spcAft>
+                <a:spcPts val="600"/>
+              </a:spcAft>
+            </a:pPr>
+            <a:r>
+              <a:rPr sz="1600">
+                <a:solidFill>
+                  <a:srgbClr val="2E75B6"/>
+                </a:solidFill>
+                <a:latin typeface="Times New Roman"/>
+              </a:rPr>
+              <a:t>      –  </a:t>
+            </a:r>
+            <a:r>
+              <a:rPr sz="1600">
+                <a:latin typeface="Times New Roman"/>
+              </a:rPr>
+              <a:t>Chỉ mục XML có lợi ở 357 bài, bất lợi ở 10.710 bài (40.490 so với 1.956 trang)</a:t>
             </a:r>
           </a:p>
         </p:txBody>
@@ -15038,7 +15122,7 @@
               </a:spcAft>
             </a:pPr>
             <a:r>
-              <a:rPr sz="1200">
+              <a:rPr sz="1100">
                 <a:solidFill>
                   <a:srgbClr val="2E75B6"/>
                 </a:solidFill>
@@ -15047,7 +15131,7 @@
               <a:t>■  </a:t>
             </a:r>
             <a:r>
-              <a:rPr sz="1800" b="1">
+              <a:rPr sz="1700" b="1">
                 <a:solidFill>
                   <a:srgbClr val="1F3864"/>
                 </a:solidFill>
@@ -15056,10 +15140,10 @@
               <a:t>Xác thực: </a:t>
             </a:r>
             <a:r>
-              <a:rPr sz="1800">
-                <a:latin typeface="Times New Roman"/>
-              </a:rPr>
-              <a:t>login SQL theo vai trò; tài khoản ứng dụng băm SHA2_256 + salt, khoá sau 5 lần sai</a:t>
+              <a:rPr sz="1700">
+                <a:latin typeface="Times New Roman"/>
+              </a:rPr>
+              <a:t>băm lặp 10.000 vòng SHA2_256 + salt; sai 5 lần → tạm khoá 15 phút; thông báo chung không lộ tài khoản</a:t>
             </a:r>
           </a:p>
           <a:p>
@@ -15069,7 +15153,7 @@
               </a:spcAft>
             </a:pPr>
             <a:r>
-              <a:rPr sz="1200">
+              <a:rPr sz="1100">
                 <a:solidFill>
                   <a:srgbClr val="2E75B6"/>
                 </a:solidFill>
@@ -15078,7 +15162,7 @@
               <a:t>■  </a:t>
             </a:r>
             <a:r>
-              <a:rPr sz="1800" b="1">
+              <a:rPr sz="1700" b="1">
                 <a:solidFill>
                   <a:srgbClr val="1F3864"/>
                 </a:solidFill>
@@ -15087,10 +15171,10 @@
               <a:t>Phân quyền: </a:t>
             </a:r>
             <a:r>
-              <a:rPr sz="1800">
-                <a:latin typeface="Times New Roman"/>
-              </a:rPr>
-              <a:t>5 role, ứng dụng dùng login ecms_app bị DENY trên mọi bảng – chỉ EXECUTE procedure, SELECT view</a:t>
+              <a:rPr sz="1700">
+                <a:latin typeface="Times New Roman"/>
+              </a:rPr>
+              <a:t>6 role; login ecms_app bị DENY trên mọi bảng – chỉ EXECUTE procedure, SELECT view</a:t>
             </a:r>
           </a:p>
           <a:p>
@@ -15100,7 +15184,7 @@
               </a:spcAft>
             </a:pPr>
             <a:r>
-              <a:rPr sz="1200">
+              <a:rPr sz="1100">
                 <a:solidFill>
                   <a:srgbClr val="2E75B6"/>
                 </a:solidFill>
@@ -15109,19 +15193,10 @@
               <a:t>■  </a:t>
             </a:r>
             <a:r>
-              <a:rPr sz="1800" b="1">
-                <a:solidFill>
-                  <a:srgbClr val="1F3864"/>
-                </a:solidFill>
-                <a:latin typeface="Times New Roman"/>
-              </a:rPr>
-              <a:t>Row-level: </a:t>
-            </a:r>
-            <a:r>
-              <a:rPr sz="1800">
-                <a:latin typeface="Times New Roman"/>
-              </a:rPr>
-              <a:t>SESSION_CONTEXT lọc dữ liệu theo chi nhánh; ẩn lương với vai trò không liên quan</a:t>
+              <a:rPr sz="1700">
+                <a:latin typeface="Times New Roman"/>
+              </a:rPr>
+              <a:t>SESSION_CONTEXT @read_only = 1, một kết nối mỗi phiên; kiểm tra quyền fail-closed theo chi nhánh</a:t>
             </a:r>
           </a:p>
           <a:p>
@@ -15131,7 +15206,7 @@
               </a:spcAft>
             </a:pPr>
             <a:r>
-              <a:rPr sz="1200">
+              <a:rPr sz="1100">
                 <a:solidFill>
                   <a:srgbClr val="2E75B6"/>
                 </a:solidFill>
@@ -15140,10 +15215,41 @@
               <a:t>■  </a:t>
             </a:r>
             <a:r>
-              <a:rPr sz="1800">
-                <a:latin typeface="Times New Roman"/>
-              </a:rPr>
-              <a:t>36 ca kiểm thử phân quyền đều PASS</a:t>
+              <a:rPr sz="1700" b="1">
+                <a:solidFill>
+                  <a:srgbClr val="1F3864"/>
+                </a:solidFill>
+                <a:latin typeface="Times New Roman"/>
+              </a:rPr>
+              <a:t>Mã hoá &amp; kiểm toán: </a:t>
+            </a:r>
+            <a:r>
+              <a:rPr sz="1700">
+                <a:latin typeface="Times New Roman"/>
+              </a:rPr>
+              <a:t>TLS, TDE, mã hoá cột, che dữ liệu, SQL Server Audit, ledger</a:t>
+            </a:r>
+          </a:p>
+          <a:p>
+            <a:pPr>
+              <a:spcAft>
+                <a:spcPts val="600"/>
+              </a:spcAft>
+            </a:pPr>
+            <a:r>
+              <a:rPr sz="1100">
+                <a:solidFill>
+                  <a:srgbClr val="2E75B6"/>
+                </a:solidFill>
+                <a:latin typeface="Times New Roman"/>
+              </a:rPr>
+              <a:t>■  </a:t>
+            </a:r>
+            <a:r>
+              <a:rPr sz="1700">
+                <a:latin typeface="Times New Roman"/>
+              </a:rPr>
+              <a:t>50 ca kiểm thử phân quyền đều PASS</a:t>
             </a:r>
           </a:p>
         </p:txBody>
@@ -15176,7 +15282,7 @@
               </a:spcAft>
             </a:pPr>
             <a:r>
-              <a:rPr sz="1200">
+              <a:rPr sz="1100">
                 <a:solidFill>
                   <a:srgbClr val="2E75B6"/>
                 </a:solidFill>
@@ -15185,7 +15291,7 @@
               <a:t>■  </a:t>
             </a:r>
             <a:r>
-              <a:rPr sz="1800" b="1">
+              <a:rPr sz="1700" b="1">
                 <a:solidFill>
                   <a:srgbClr val="1F3864"/>
                 </a:solidFill>
@@ -15194,7 +15300,7 @@
               <a:t>View: </a:t>
             </a:r>
             <a:r>
-              <a:rPr sz="1800">
+              <a:rPr sz="1700">
                 <a:latin typeface="Times New Roman"/>
               </a:rPr>
               <a:t>27 view – bảo mật, báo cáo, indexed view doanh thu, WITH CHECK OPTION</a:t>
@@ -15207,7 +15313,7 @@
               </a:spcAft>
             </a:pPr>
             <a:r>
-              <a:rPr sz="1200">
+              <a:rPr sz="1100">
                 <a:solidFill>
                   <a:srgbClr val="2E75B6"/>
                 </a:solidFill>
@@ -15216,7 +15322,7 @@
               <a:t>■  </a:t>
             </a:r>
             <a:r>
-              <a:rPr sz="1800" b="1">
+              <a:rPr sz="1700" b="1">
                 <a:solidFill>
                   <a:srgbClr val="1F3864"/>
                 </a:solidFill>
@@ -15225,10 +15331,10 @@
               <a:t>Sao lưu: </a:t>
             </a:r>
             <a:r>
-              <a:rPr sz="1800">
-                <a:latin typeface="Times New Roman"/>
-              </a:rPr>
-              <a:t>FULL tuần, DIFF ngày, LOG 15 phút → RPO 15 phút</a:t>
+              <a:rPr sz="1700">
+                <a:latin typeface="Times New Roman"/>
+              </a:rPr>
+              <a:t>FULL tuần, DIFF ngày, LOG 15 phút → RPO 15 phút; bản sao lưu mã hoá AES-256</a:t>
             </a:r>
           </a:p>
           <a:p>
@@ -15238,7 +15344,7 @@
               </a:spcAft>
             </a:pPr>
             <a:r>
-              <a:rPr sz="1200">
+              <a:rPr sz="1100">
                 <a:solidFill>
                   <a:srgbClr val="2E75B6"/>
                 </a:solidFill>
@@ -15247,10 +15353,19 @@
               <a:t>■  </a:t>
             </a:r>
             <a:r>
-              <a:rPr sz="1800">
-                <a:latin typeface="Times New Roman"/>
-              </a:rPr>
-              <a:t>Phục hồi theo thời điểm (STOPAT) ra CSDL song song để đối chiếu</a:t>
+              <a:rPr sz="1700" b="1">
+                <a:solidFill>
+                  <a:srgbClr val="1F3864"/>
+                </a:solidFill>
+                <a:latin typeface="Times New Roman"/>
+              </a:rPr>
+              <a:t>Phục hồi theo thời điểm (STOPAT): </a:t>
+            </a:r>
+            <a:r>
+              <a:rPr sz="1700">
+                <a:latin typeface="Times New Roman"/>
+              </a:rPr>
+              <a:t>RTO đo được 723–810 ms; DBCC CHECKDB; 3 job Agent</a:t>
             </a:r>
           </a:p>
           <a:p>
@@ -15260,7 +15375,7 @@
               </a:spcAft>
             </a:pPr>
             <a:r>
-              <a:rPr sz="1200">
+              <a:rPr sz="1100">
                 <a:solidFill>
                   <a:srgbClr val="2E75B6"/>
                 </a:solidFill>
@@ -15269,7 +15384,7 @@
               <a:t>■  </a:t>
             </a:r>
             <a:r>
-              <a:rPr sz="1800" b="1">
+              <a:rPr sz="1700" b="1">
                 <a:solidFill>
                   <a:srgbClr val="1F3864"/>
                 </a:solidFill>
@@ -15278,10 +15393,10 @@
               <a:t>Nhập / xuất: </a:t>
             </a:r>
             <a:r>
-              <a:rPr sz="1800">
-                <a:latin typeface="Times New Roman"/>
-              </a:rPr>
-              <a:t>BULK INSERT, bcp, FOR JSON / XML, pandas – kiểm tra và báo dòng lỗi</a:t>
+              <a:rPr sz="1700">
+                <a:latin typeface="Times New Roman"/>
+              </a:rPr>
+              <a:t>ETL qua bảng tạm, 12 quy tắc kiểm tra, CSV / XML / JSON / Excel</a:t>
             </a:r>
           </a:p>
         </p:txBody>
@@ -15674,7 +15789,7 @@
                           </a:solidFill>
                           <a:latin typeface="Times New Roman"/>
                         </a:rPr>
-                        <a:t>38</a:t>
+                        <a:t>40</a:t>
                       </a:r>
                     </a:p>
                   </a:txBody>
@@ -15697,7 +15812,7 @@
                           </a:solidFill>
                           <a:latin typeface="Times New Roman"/>
                         </a:rPr>
-                        <a:t>sp_DangKyHoc, sp_ThuHocPhi (JSON master–detail, SAVE TRANSACTION)</a:t>
+                        <a:t>sp_DangKyHoc, sp_ThuHocPhi (JSON master–detail, savepoint, khoá ứng dụng)</a:t>
                       </a:r>
                     </a:p>
                   </a:txBody>
@@ -15720,7 +15835,7 @@
                           </a:solidFill>
                           <a:latin typeface="Times New Roman"/>
                         </a:rPr>
-                        <a:t>25 ca PASS</a:t>
+                        <a:t>37 ca PASS</a:t>
                       </a:r>
                     </a:p>
                   </a:txBody>
@@ -15768,7 +15883,7 @@
                           </a:solidFill>
                           <a:latin typeface="Times New Roman"/>
                         </a:rPr>
-                        <a:t>13</a:t>
+                        <a:t>17</a:t>
                       </a:r>
                     </a:p>
                   </a:txBody>
@@ -15791,7 +15906,7 @@
                           </a:solidFill>
                           <a:latin typeface="Times New Roman"/>
                         </a:rPr>
-                        <a:t>fn_GoiYKhoaHoc, fn_BangDiemLop (inline / multi-statement TVF)</a:t>
+                        <a:t>fn_GoiYKhoaHoc, fn_BangDiemLop, fn_NguoiDungHienTai (phân quyền)</a:t>
                       </a:r>
                     </a:p>
                   </a:txBody>
@@ -15862,7 +15977,7 @@
                           </a:solidFill>
                           <a:latin typeface="Times New Roman"/>
                         </a:rPr>
-                        <a:t>11</a:t>
+                        <a:t>14</a:t>
                       </a:r>
                     </a:p>
                   </a:txBody>
@@ -15908,7 +16023,7 @@
                           </a:solidFill>
                           <a:latin typeface="Times New Roman"/>
                         </a:rPr>
-                        <a:t>17 ca PASS</a:t>
+                        <a:t>22 ca PASS</a:t>
                       </a:r>
                     </a:p>
                   </a:txBody>
@@ -16002,7 +16117,7 @@
                           </a:solidFill>
                           <a:latin typeface="Times New Roman"/>
                         </a:rPr>
-                        <a:t>so sánh set-based</a:t>
+                        <a:t>set-based nhanh 1,1–6,9×</a:t>
                       </a:r>
                     </a:p>
                   </a:txBody>
@@ -16059,7 +16174,7 @@
                 </a:solidFill>
                 <a:latin typeface="Times New Roman"/>
               </a:rPr>
-              <a:t>Mọi nghiệp vụ nhiều bước chạy trong transaction lồng được; trigger viết set-based.</a:t>
+              <a:t>XACT_ABORT + savepoint, sp_getapplock / UPDLOCK chống tranh chấp, mã yêu cầu chống lập phiếu thu trùng.</a:t>
             </a:r>
           </a:p>
         </p:txBody>

</xml_diff>

<commit_message>
docs: ảnh, số liệu và PDF dựng trên Windows (SQL Server 2025 Developer) sau khi khắc phục review (#66)
- 25 ảnh màn hình chụp lại bằng scripts/chup_anh.py --ghi trên CSDL dựng mới
- Chương 3: thông báo đăng nhập khi đang khoá, mã yêu cầu phiếu thu (50016), phạm vi chi nhánh của
  sp_ThuHocPhi / sp_ChuyenLop, lịch job log từ 00:00, RTO trên Windows 607–735 ms, Bảng 3.29 tốc độ
  nhập trên hai môi trường (Docker macOS / Windows cùng máy), bản mã cột lương, 39 / 22 / 53 ca kiểm thử
- Chương 5: kiểm chứng migrate / compare trên Windows; Chương 4, 6, HDSD, README, slide cập nhật theo
- Báo cáo 232 trang, hướng dẫn sử dụng 55 trang (xuất PDF bằng Word – scripts/export_pdf.ps1)
</commit_message>
<xml_diff>
--- a/slides/ECMS_Nhom1.pptx
+++ b/slides/ECMS_Nhom1.pptx
@@ -5761,8 +5761,8 @@
         </p:blipFill>
         <p:spPr>
           <a:xfrm>
-            <a:off x="8682743" y="1044000"/>
-            <a:ext cx="2218513" cy="2556000"/>
+            <a:off x="8684443" y="1044000"/>
+            <a:ext cx="2215112" cy="2556000"/>
           </a:xfrm>
           <a:prstGeom prst="rect">
             <a:avLst/>
@@ -6152,8 +6152,8 @@
         </p:blipFill>
         <p:spPr>
           <a:xfrm>
-            <a:off x="1381774" y="1044000"/>
-            <a:ext cx="3716452" cy="3528000"/>
+            <a:off x="1378305" y="1044000"/>
+            <a:ext cx="3723390" cy="3528000"/>
           </a:xfrm>
           <a:prstGeom prst="rect">
             <a:avLst/>
@@ -6181,8 +6181,8 @@
         </p:blipFill>
         <p:spPr>
           <a:xfrm>
-            <a:off x="7327700" y="1044000"/>
-            <a:ext cx="3344599" cy="3528000"/>
+            <a:off x="7325829" y="1044000"/>
+            <a:ext cx="3348342" cy="3528000"/>
           </a:xfrm>
           <a:prstGeom prst="rect">
             <a:avLst/>
@@ -6513,8 +6513,8 @@
         </p:blipFill>
         <p:spPr>
           <a:xfrm>
-            <a:off x="2613616" y="1044000"/>
-            <a:ext cx="1756768" cy="3816000"/>
+            <a:off x="2612900" y="1044000"/>
+            <a:ext cx="1758200" cy="3816000"/>
           </a:xfrm>
           <a:prstGeom prst="rect">
             <a:avLst/>
@@ -8262,7 +8262,7 @@
                           </a:solidFill>
                           <a:latin typeface="Times New Roman"/>
                         </a:rPr>
-                        <a:t>37 / 22 / 50 ca PASS</a:t>
+                        <a:t>39 / 22 / 53 ca PASS</a:t>
                       </a:r>
                     </a:p>
                   </a:txBody>
@@ -15249,7 +15249,7 @@
               <a:rPr sz="1700">
                 <a:latin typeface="Times New Roman"/>
               </a:rPr>
-              <a:t>50 ca kiểm thử phân quyền đều PASS</a:t>
+              <a:t>53 ca kiểm thử phân quyền đều PASS</a:t>
             </a:r>
           </a:p>
         </p:txBody>
@@ -15365,7 +15365,7 @@
               <a:rPr sz="1700">
                 <a:latin typeface="Times New Roman"/>
               </a:rPr>
-              <a:t>RTO đo được 723–810 ms; DBCC CHECKDB; 3 job Agent</a:t>
+              <a:t>RTO đo được 607–810 ms; DBCC CHECKDB; 3 job Agent</a:t>
             </a:r>
           </a:p>
           <a:p>
@@ -15835,7 +15835,7 @@
                           </a:solidFill>
                           <a:latin typeface="Times New Roman"/>
                         </a:rPr>
-                        <a:t>37 ca PASS</a:t>
+                        <a:t>39 ca PASS</a:t>
                       </a:r>
                     </a:p>
                   </a:txBody>

</xml_diff>

<commit_message>
docs: 2PC qua MSDTC giữa Windows và macOS vào Chương 5, hạn chế Chương 6, SETUP, slide (#66)
</commit_message>
<xml_diff>
--- a/slides/ECMS_Nhom1.pptx
+++ b/slides/ECMS_Nhom1.pptx
@@ -7753,7 +7753,7 @@
                           </a:solidFill>
                           <a:latin typeface="Times New Roman"/>
                         </a:rPr>
-                        <a:t>3 trạm, nửa kết −73% byte, 2PC</a:t>
+                        <a:t>3 trạm, nửa kết −73% byte, 2PC qua MSDTC 2 máy</a:t>
                       </a:r>
                     </a:p>
                   </a:txBody>
@@ -10625,7 +10625,7 @@
               <a:rPr sz="1900">
                 <a:latin typeface="Times New Roman"/>
               </a:rPr>
-              <a:t>dữ liệu nhỏ, chưa có phím tắt và giao diện di động, phân tán mô phỏng trên 1 máy (MSDTC 2 máy chạy trên Windows)</a:t>
+              <a:t>dữ liệu nhỏ, chưa có phím tắt và giao diện di động, phân tán phần lớn mô phỏng trên 1 máy (2PC qua MSDTC đã chạy thật giữa Windows và macOS)</a:t>
             </a:r>
           </a:p>
         </p:txBody>

</xml_diff>